<commit_message>
New logo test files
</commit_message>
<xml_diff>
--- a/awyiss/Command/Media/TestFiles/logo-awyiss.pptx
+++ b/awyiss/Command/Media/TestFiles/logo-awyiss.pptx
@@ -104,6 +104,11 @@
       </a:defRPr>
     </a:lvl9pPr>
   </p:defaultTextStyle>
+  <p:extLst>
+    <p:ext uri="{EFAFB233-063F-42B5-8137-9DF3F51BA10A}">
+      <p15:sldGuideLst xmlns:p15="http://schemas.microsoft.com/office/powerpoint/2012/main"/>
+    </p:ext>
+  </p:extLst>
 </p:presentation>
 </file>
 
@@ -254,7 +259,7 @@
           <a:p>
             <a:fld id="{3A4CAA72-4632-4DEA-9E4B-7DBC1C9B0C3B}" type="datetimeFigureOut">
               <a:rPr lang="de-DE" smtClean="0"/>
-              <a:t>14.02.2024</a:t>
+              <a:t>20.06.2024</a:t>
             </a:fld>
             <a:endParaRPr lang="de-DE"/>
           </a:p>
@@ -452,7 +457,7 @@
           <a:p>
             <a:fld id="{3A4CAA72-4632-4DEA-9E4B-7DBC1C9B0C3B}" type="datetimeFigureOut">
               <a:rPr lang="de-DE" smtClean="0"/>
-              <a:t>14.02.2024</a:t>
+              <a:t>20.06.2024</a:t>
             </a:fld>
             <a:endParaRPr lang="de-DE"/>
           </a:p>
@@ -660,7 +665,7 @@
           <a:p>
             <a:fld id="{3A4CAA72-4632-4DEA-9E4B-7DBC1C9B0C3B}" type="datetimeFigureOut">
               <a:rPr lang="de-DE" smtClean="0"/>
-              <a:t>14.02.2024</a:t>
+              <a:t>20.06.2024</a:t>
             </a:fld>
             <a:endParaRPr lang="de-DE"/>
           </a:p>
@@ -858,7 +863,7 @@
           <a:p>
             <a:fld id="{3A4CAA72-4632-4DEA-9E4B-7DBC1C9B0C3B}" type="datetimeFigureOut">
               <a:rPr lang="de-DE" smtClean="0"/>
-              <a:t>14.02.2024</a:t>
+              <a:t>20.06.2024</a:t>
             </a:fld>
             <a:endParaRPr lang="de-DE"/>
           </a:p>
@@ -1133,7 +1138,7 @@
           <a:p>
             <a:fld id="{3A4CAA72-4632-4DEA-9E4B-7DBC1C9B0C3B}" type="datetimeFigureOut">
               <a:rPr lang="de-DE" smtClean="0"/>
-              <a:t>14.02.2024</a:t>
+              <a:t>20.06.2024</a:t>
             </a:fld>
             <a:endParaRPr lang="de-DE"/>
           </a:p>
@@ -1398,7 +1403,7 @@
           <a:p>
             <a:fld id="{3A4CAA72-4632-4DEA-9E4B-7DBC1C9B0C3B}" type="datetimeFigureOut">
               <a:rPr lang="de-DE" smtClean="0"/>
-              <a:t>14.02.2024</a:t>
+              <a:t>20.06.2024</a:t>
             </a:fld>
             <a:endParaRPr lang="de-DE"/>
           </a:p>
@@ -1810,7 +1815,7 @@
           <a:p>
             <a:fld id="{3A4CAA72-4632-4DEA-9E4B-7DBC1C9B0C3B}" type="datetimeFigureOut">
               <a:rPr lang="de-DE" smtClean="0"/>
-              <a:t>14.02.2024</a:t>
+              <a:t>20.06.2024</a:t>
             </a:fld>
             <a:endParaRPr lang="de-DE"/>
           </a:p>
@@ -1951,7 +1956,7 @@
           <a:p>
             <a:fld id="{3A4CAA72-4632-4DEA-9E4B-7DBC1C9B0C3B}" type="datetimeFigureOut">
               <a:rPr lang="de-DE" smtClean="0"/>
-              <a:t>14.02.2024</a:t>
+              <a:t>20.06.2024</a:t>
             </a:fld>
             <a:endParaRPr lang="de-DE"/>
           </a:p>
@@ -2064,7 +2069,7 @@
           <a:p>
             <a:fld id="{3A4CAA72-4632-4DEA-9E4B-7DBC1C9B0C3B}" type="datetimeFigureOut">
               <a:rPr lang="de-DE" smtClean="0"/>
-              <a:t>14.02.2024</a:t>
+              <a:t>20.06.2024</a:t>
             </a:fld>
             <a:endParaRPr lang="de-DE"/>
           </a:p>
@@ -2375,7 +2380,7 @@
           <a:p>
             <a:fld id="{3A4CAA72-4632-4DEA-9E4B-7DBC1C9B0C3B}" type="datetimeFigureOut">
               <a:rPr lang="de-DE" smtClean="0"/>
-              <a:t>14.02.2024</a:t>
+              <a:t>20.06.2024</a:t>
             </a:fld>
             <a:endParaRPr lang="de-DE"/>
           </a:p>
@@ -2663,7 +2668,7 @@
           <a:p>
             <a:fld id="{3A4CAA72-4632-4DEA-9E4B-7DBC1C9B0C3B}" type="datetimeFigureOut">
               <a:rPr lang="de-DE" smtClean="0"/>
-              <a:t>14.02.2024</a:t>
+              <a:t>20.06.2024</a:t>
             </a:fld>
             <a:endParaRPr lang="de-DE"/>
           </a:p>
@@ -2904,7 +2909,7 @@
           <a:p>
             <a:fld id="{3A4CAA72-4632-4DEA-9E4B-7DBC1C9B0C3B}" type="datetimeFigureOut">
               <a:rPr lang="de-DE" smtClean="0"/>
-              <a:t>14.02.2024</a:t>
+              <a:t>20.06.2024</a:t>
             </a:fld>
             <a:endParaRPr lang="de-DE"/>
           </a:p>
@@ -3354,69 +3359,42 @@
           </a:p>
         </p:txBody>
       </p:sp>
-      <p:graphicFrame>
-        <p:nvGraphicFramePr>
-          <p:cNvPr id="4" name="Objekt 3">
-            <a:extLst>
-              <a:ext uri="{FF2B5EF4-FFF2-40B4-BE49-F238E27FC236}">
-                <a16:creationId xmlns:a16="http://schemas.microsoft.com/office/drawing/2014/main" id="{C408682E-FF82-66AD-EFDD-B5F42CBA1E4F}"/>
-              </a:ext>
-            </a:extLst>
-          </p:cNvPr>
-          <p:cNvGraphicFramePr>
-            <a:graphicFrameLocks noChangeAspect="1"/>
-          </p:cNvGraphicFramePr>
-          <p:nvPr>
-            <p:extLst>
-              <p:ext uri="{D42A27DB-BD31-4B8C-83A1-F6EECF244321}">
-                <p14:modId xmlns:p14="http://schemas.microsoft.com/office/powerpoint/2010/main" val="708289635"/>
-              </p:ext>
-            </p:extLst>
-          </p:nvPr>
-        </p:nvGraphicFramePr>
-        <p:xfrm>
-          <a:off x="5326083" y="3825360"/>
-          <a:ext cx="1539834" cy="736022"/>
-        </p:xfrm>
-        <a:graphic>
-          <a:graphicData uri="http://schemas.openxmlformats.org/presentationml/2006/ole">
-            <mc:AlternateContent xmlns:mc="http://schemas.openxmlformats.org/markup-compatibility/2006">
-              <mc:Choice xmlns:v="urn:schemas-microsoft-com:vml" Requires="v">
-                <p:oleObj r:id="rId2" imgW="4542840" imgH="2171160" progId="">
-                  <p:embed/>
-                </p:oleObj>
-              </mc:Choice>
-              <mc:Fallback>
-                <p:oleObj r:id="rId2" imgW="4542840" imgH="2171160" progId="">
-                  <p:embed/>
-                  <p:pic>
-                    <p:nvPicPr>
-                      <p:cNvPr id="0" name=""/>
-                      <p:cNvPicPr/>
-                      <p:nvPr/>
-                    </p:nvPicPr>
-                    <p:blipFill>
-                      <a:blip r:embed="rId3"/>
-                      <a:stretch>
-                        <a:fillRect/>
-                      </a:stretch>
-                    </p:blipFill>
-                    <p:spPr>
-                      <a:xfrm>
-                        <a:off x="5326083" y="3825360"/>
-                        <a:ext cx="1539834" cy="736022"/>
-                      </a:xfrm>
-                      <a:prstGeom prst="rect">
-                        <a:avLst/>
-                      </a:prstGeom>
-                    </p:spPr>
-                  </p:pic>
-                </p:oleObj>
-              </mc:Fallback>
-            </mc:AlternateContent>
-          </a:graphicData>
-        </a:graphic>
-      </p:graphicFrame>
+      <p:pic>
+        <p:nvPicPr>
+          <p:cNvPr id="7" name="Grafik 6">
+            <a:extLst>
+              <a:ext uri="{FF2B5EF4-FFF2-40B4-BE49-F238E27FC236}">
+                <a16:creationId xmlns:a16="http://schemas.microsoft.com/office/drawing/2014/main" id="{80BEE986-F63B-E8DC-54DC-2FAAB6EEBEFF}"/>
+              </a:ext>
+            </a:extLst>
+          </p:cNvPr>
+          <p:cNvPicPr>
+            <a:picLocks noChangeAspect="1"/>
+          </p:cNvPicPr>
+          <p:nvPr/>
+        </p:nvPicPr>
+        <p:blipFill>
+          <a:blip r:embed="rId2">
+            <a:extLst>
+              <a:ext uri="{28A0092B-C50C-407E-A947-70E740481C1C}">
+                <a14:useLocalDpi xmlns:a14="http://schemas.microsoft.com/office/drawing/2010/main" val="0"/>
+              </a:ext>
+            </a:extLst>
+          </a:blip>
+          <a:stretch>
+            <a:fillRect/>
+          </a:stretch>
+        </p:blipFill>
+        <p:spPr>
+          <a:xfrm>
+            <a:off x="4181697" y="3836276"/>
+            <a:ext cx="3828606" cy="1202254"/>
+          </a:xfrm>
+          <a:prstGeom prst="rect">
+            <a:avLst/>
+          </a:prstGeom>
+        </p:spPr>
+      </p:pic>
     </p:spTree>
     <p:extLst>
       <p:ext uri="{BB962C8B-B14F-4D97-AF65-F5344CB8AC3E}">

</xml_diff>